<commit_message>
Sjöskolan vecka 43–44 som dagar: I dag, lektionsdagar, Hela veckan och Din del
Veckosidorna för vecka 43 och 44 och alla deras delsidor (också delarna i
vecka-45/) visas som vecka 42. Övningarnas läge räknas per lektion ur läxans
text och länk och ur bilderna Övningar tillsammans, inte alltid 1–5 och 6–10.
Läsläxorna nämner knappen Jag har läst, del 4 i vecka 43 har sin läsläxa och
felsökningsrapporten och analysen av mätdata länkar till inlämning 4 i sin
vecka. Åtta presentationer ombyggda. Sista dagen skrivs med rätt veckodag.

Co-Authored-By: Claude Opus 5.5 <noreply@anthropic.com>
Claude-Session: https://claude.ai/code/session_01E6DNWu8trXB9zSZC1cgTtp
</commit_message>
<xml_diff>
--- a/sjoskolan/vecka-43/aktuell/v43_02_Transformatorer_och_motorer_elev.pptx
+++ b/sjoskolan/vecka-43/aktuell/v43_02_Transformatorer_och_motorer_elev.pptx
@@ -8120,7 +8120,7 @@
                 </a:solidFill>
                 <a:latin typeface="Calibri"/>
               </a:rPr>
-              <a:t>1. Läs del 2: teorin och de två exemplen.</a:t>
+              <a:t>1. Läs del 2: teorin och de två exemplen. Tryck på ”Jag har läst del 2” längst ned på sidan.</a:t>
             </a:r>
           </a:p>
           <a:p>
@@ -8158,7 +8158,7 @@
                 </a:solidFill>
                 <a:latin typeface="Calibri"/>
               </a:rPr>
-              <a:t>3. Läs del 3, Elscheman och dokumentation, på egen hand.</a:t>
+              <a:t>3. Läs del 3, Elscheman och dokumentation, på egen hand. Tryck på ”Jag har läst del 3” längst ned på sidan.</a:t>
             </a:r>
           </a:p>
           <a:p>

</xml_diff>

<commit_message>
Separate Week 43 classroom motor calculation from assessment
Use a ten-pole 60 Hz motor at 684 r/min for exercise 2.5, with complete synchronous-speed and slip working. Rebuild student pages and the 21-slide presentation, PDF and slideshow. Keep assessment content, marking hashes, exercise anchors and saved progress unchanged. Preserve the book original as a separate record.

Validation: all generated files current; 21 Python content tests and 19 Node checks pass, with one optional private-answer check skipped. Independently checked results and hint values against all 40 weekly exercises and the assessed motor cases. Assessment files and book source are byte-identical. Revised PDF visually inspected; only slide 12 text changes. Teacher Google Doc updated and read back. Local Chromium UI test could not launch because the host prohibits its socket creation.
</commit_message>
<xml_diff>
--- a/sjoskolan/vecka-43/aktuell/v43_02_Transformatorer_och_motorer_elev.pptx
+++ b/sjoskolan/vecka-43/aktuell/v43_02_Transformatorer_och_motorer_elev.pptx
@@ -4888,7 +4888,7 @@
                 </a:solidFill>
                 <a:latin typeface="Calibri"/>
               </a:rPr>
-              <a:t>Eftersläpning</a:t>
+              <a:t>Varvtal och eftersläpning</a:t>
             </a:r>
           </a:p>
         </p:txBody>
@@ -4930,7 +4930,7 @@
                 </a:solidFill>
                 <a:latin typeface="Calibri"/>
               </a:rPr>
-              <a:t>Fem minuter. Skriv ditt svar i chatten. Övning 2.6–2.10 gör du själv efter lektionen.</a:t>
+              <a:t>Fem minuter. Skriv synkront varvtal i r/min och eftersläpning i procent i chatten. Övning 2.6–2.10 gör du själv efter lektionen.</a:t>
             </a:r>
           </a:p>
           <a:p>

</xml_diff>